<commit_message>
Corrección de errores en algunos archivos del proyecto y adición de un diccionario de datos
</commit_message>
<xml_diff>
--- a/Documents/Sustentacion.pptx
+++ b/Documents/Sustentacion.pptx
@@ -3339,7 +3339,7 @@
                 </a:solidFill>
                 <a:latin typeface="Calibri"/>
               </a:rPr>
-              <a:t>Carlos David Moreno  ·  Mayo 2026</a:t>
+              <a:t>Carlos Alberto Moreno David · Juan Esteban García Ocampo · Emiliano Vélez Suárez · Sebastián Ciro Medellín  ·  Mayo 2026</a:t>
             </a:r>
           </a:p>
         </p:txBody>
@@ -10722,7 +10722,7 @@
                 </a:solidFill>
                 <a:latin typeface="Calibri"/>
               </a:rPr>
-              <a:t>Carlos David Moreno · admmoreno.david@gmail.com · Mayo 2026</a:t>
+              <a:t>Carlos Alberto Moreno David · Juan Esteban García Ocampo · Emiliano Vélez Suárez · Sebastián Ciro Medellín · admmoreno.david@gmail.com · Mayo 2026</a:t>
             </a:r>
           </a:p>
         </p:txBody>

</xml_diff>